<commit_message>
State live AI provider: Azure OpenAI (Azure AI Foundry) in use, Anthropic configured, providers configurable; rebuild decks
Co-Authored-By: Claude Opus 5.5 <noreply@anthropic.com>
Claude-Session: https://claude.ai/code/session_0187BP1GWSVxxcKNLw65gBqQ
</commit_message>
<xml_diff>
--- a/_designs/deck/TransferHub-Demo.pptx
+++ b/_designs/deck/TransferHub-Demo.pptx
@@ -119,13 +119,13 @@
   <p:extLst>
     <p:ext uri="{521415D9-36F7-43E2-AB2F-B90AF26B5E84}">
       <p14:sectionLst xmlns:p14="http://schemas.microsoft.com/office/powerpoint/2010/main">
-        <p14:section name="Opening" id="{77fc6eb0-9fbf-dcda-ec89-ef147dff264c}">
+        <p14:section name="Opening" id="{317dcbb7-44f3-4546-4e3c-40a00f6eec6e}">
           <p14:sldIdLst>
             <p14:sldId id="256"/>
             <p14:sldId id="257"/>
           </p14:sldIdLst>
         </p14:section>
-        <p14:section name="Student" id="{609487bb-4a37-ab4f-ba4c-f4bb53f439d8}">
+        <p14:section name="Student" id="{19961f48-de27-b0d9-2113-6eed177b8e02}">
           <p14:sldIdLst>
             <p14:sldId id="258"/>
             <p14:sldId id="259"/>
@@ -134,19 +134,19 @@
             <p14:sldId id="262"/>
           </p14:sldIdLst>
         </p14:section>
-        <p14:section name="Staff" id="{ecc7685e-8cef-65ac-55b7-9c9a2e14fe31}">
+        <p14:section name="Staff" id="{c934eb28-d874-2c86-bd35-49bfe38bcc38}">
           <p14:sldIdLst>
             <p14:sldId id="263"/>
             <p14:sldId id="264"/>
             <p14:sldId id="265"/>
           </p14:sldIdLst>
         </p14:section>
-        <p14:section name="Super admin" id="{399690f4-365b-76b7-ca36-c4cea3ecc660}">
+        <p14:section name="Super admin" id="{ac5aa165-2454-0a6a-cef9-d71803b8e498}">
           <p14:sldIdLst>
             <p14:sldId id="266"/>
           </p14:sldIdLst>
         </p14:section>
-        <p14:section name="Close" id="{f03fb9ac-4bff-5028-f5bf-7ddc15a4ea88}">
+        <p14:section name="Close" id="{3e22567e-a992-c7ea-e797-149df8e3e5c1}">
           <p14:sldIdLst>
             <p14:sldId id="267"/>
             <p14:sldId id="268"/>
@@ -732,7 +732,7 @@
           <a:p>
             <a:r>
               <a:rPr lang="en-US" dirty="0"/>
-              <a:t>Super admin dashboard: an "AI agents" block sits under Transfer operations, separate from the regular counts. AI Controls shows the same numbers in detail: spent this month, $ spent by request (matching / documents / briefs), tokens avoided, cache hits, response times. No AI key yet, so live AI spend is zero; the rules engine is logged at no cost.</a:t>
+              <a:t>Super admin dashboard: an "AI agents" block sits under Transfer operations, separate from the regular counts. AI Controls shows the same numbers in detail: spent this month, $ spent by request (matching / documents / briefs), tokens avoided, cache hits, response times. Spend comes from the active provider (Azure OpenAI today; Anthropic also configured); the rules engine is logged at no cost.</a:t>
             </a:r>
             <a:endParaRPr lang="en-US" dirty="0"/>
           </a:p>
@@ -1172,7 +1172,7 @@
           <a:p>
             <a:r>
               <a:rPr lang="en-US" dirty="0"/>
-              <a:t>Smart Upload: drop PDFs or photos (or use the phone camera). Each file is classified and read; the student checks and confirms. Without an AI key the built-in rules reader does it, at lower confidence.</a:t>
+              <a:t>Smart Upload: drop PDFs or photos (or use the phone camera). Each file is classified and read; the student checks and confirms. Live AI runs on Azure OpenAI (Azure AI Foundry); with no provider active the built-in rules reader does it, at lower confidence.</a:t>
             </a:r>
             <a:endParaRPr lang="en-US" dirty="0"/>
           </a:p>

</xml_diff>